<commit_message>
feat: modernize LifeFlow desktop experience
</commit_message>
<xml_diff>
--- a/output/presentation/LifeFlow_Presentation.pptx
+++ b/output/presentation/LifeFlow_Presentation.pptx
@@ -2,22 +2,22 @@
 <file path=ppt/presentation.xml><?xml version="1.0" encoding="utf-8"?>
 <p:presentation xmlns:p="http://schemas.openxmlformats.org/presentationml/2006/main">
   <p:sldMasterIdLst>
-    <p:sldMasterId xmlns:r="http://schemas.openxmlformats.org/officeDocument/2006/relationships" id="2147483648" r:id="R85c7971303424712"/>
+    <p:sldMasterId xmlns:r="http://schemas.openxmlformats.org/officeDocument/2006/relationships" id="2147483648" r:id="R7ff0692fe24e4a65"/>
   </p:sldMasterIdLst>
   <p:notesMasterIdLst>
-    <p:notesMasterId xmlns:r="http://schemas.openxmlformats.org/officeDocument/2006/relationships" r:id="R41e40baf559f45f7"/>
+    <p:notesMasterId xmlns:r="http://schemas.openxmlformats.org/officeDocument/2006/relationships" r:id="R421be14bba5f49f3"/>
   </p:notesMasterIdLst>
   <p:sldIdLst>
-    <p:sldId xmlns:r="http://schemas.openxmlformats.org/officeDocument/2006/relationships" id="256" r:id="R474c78274d7e4747"/>
-    <p:sldId xmlns:r="http://schemas.openxmlformats.org/officeDocument/2006/relationships" id="257" r:id="R14a411096df34cf7"/>
-    <p:sldId xmlns:r="http://schemas.openxmlformats.org/officeDocument/2006/relationships" id="258" r:id="R9241254a84b84446"/>
-    <p:sldId xmlns:r="http://schemas.openxmlformats.org/officeDocument/2006/relationships" id="259" r:id="Re53ad58303844f92"/>
-    <p:sldId xmlns:r="http://schemas.openxmlformats.org/officeDocument/2006/relationships" id="260" r:id="Rd58982c44b5d477c"/>
-    <p:sldId xmlns:r="http://schemas.openxmlformats.org/officeDocument/2006/relationships" id="261" r:id="R7eeea765737845d0"/>
-    <p:sldId xmlns:r="http://schemas.openxmlformats.org/officeDocument/2006/relationships" id="262" r:id="R729b8ca3d0c94fa3"/>
-    <p:sldId xmlns:r="http://schemas.openxmlformats.org/officeDocument/2006/relationships" id="263" r:id="Ra2dd1424c9e144f0"/>
-    <p:sldId xmlns:r="http://schemas.openxmlformats.org/officeDocument/2006/relationships" id="264" r:id="R20db887e1e364857"/>
-    <p:sldId xmlns:r="http://schemas.openxmlformats.org/officeDocument/2006/relationships" id="265" r:id="R438026671dd7479d"/>
+    <p:sldId xmlns:r="http://schemas.openxmlformats.org/officeDocument/2006/relationships" id="256" r:id="R13ef0c126bcd4ebb"/>
+    <p:sldId xmlns:r="http://schemas.openxmlformats.org/officeDocument/2006/relationships" id="257" r:id="R7a2e46b0add7470c"/>
+    <p:sldId xmlns:r="http://schemas.openxmlformats.org/officeDocument/2006/relationships" id="258" r:id="Rd435218ab0584be6"/>
+    <p:sldId xmlns:r="http://schemas.openxmlformats.org/officeDocument/2006/relationships" id="259" r:id="R2089d123a6b04ff8"/>
+    <p:sldId xmlns:r="http://schemas.openxmlformats.org/officeDocument/2006/relationships" id="260" r:id="Ra0b82b98147e4670"/>
+    <p:sldId xmlns:r="http://schemas.openxmlformats.org/officeDocument/2006/relationships" id="261" r:id="Rb61d98d865ec4ece"/>
+    <p:sldId xmlns:r="http://schemas.openxmlformats.org/officeDocument/2006/relationships" id="262" r:id="Ra652f7f3a9f74c8f"/>
+    <p:sldId xmlns:r="http://schemas.openxmlformats.org/officeDocument/2006/relationships" id="263" r:id="R03c94fb2c4ab4d95"/>
+    <p:sldId xmlns:r="http://schemas.openxmlformats.org/officeDocument/2006/relationships" id="264" r:id="Rd160ab69a6be4ea9"/>
+    <p:sldId xmlns:r="http://schemas.openxmlformats.org/officeDocument/2006/relationships" id="265" r:id="R35f41c0410ad4712"/>
   </p:sldIdLst>
   <p:sldSz cx="12192000" cy="6858000"/>
   <p:notesSz cx="6858000" cy="9144000"/>
@@ -756,7 +756,7 @@
           <a:lstStyle xmlns:a="http://schemas.openxmlformats.org/drawingml/2006/main"/>
           <a:p xmlns:a="http://schemas.openxmlformats.org/drawingml/2006/main">
             <a:r>
-              <a:t>Use this slide as the demo map. Show how a user moves from Donors to Inventory to Requests and finally Matching.</a:t>
+              <a:t>Use this slide as the demo map. Start from the dashboard, use a quick action, and then open Matching to process the emergency request.</a:t>
             </a:r>
           </a:p>
         </p:txBody>
@@ -826,7 +826,7 @@
           <a:lstStyle xmlns:a="http://schemas.openxmlformats.org/drawingml/2006/main"/>
           <a:p xmlns:a="http://schemas.openxmlformats.org/drawingml/2006/main">
             <a:r>
-              <a:t>Explain that no framework, database, or design-pattern layer is added. Each package has one clear responsibility, which keeps the code understandable for a course demonstration.</a:t>
+              <a:t>Explain that no external UI framework or database is added. LifeFlowController keeps validation and persistence out of the Swing pages while the UI remains standard Java.</a:t>
             </a:r>
           </a:p>
         </p:txBody>
@@ -1194,7 +1194,7 @@
   </p:cSld>
   <p:clrMap bg1="lt1" tx1="dk1" bg2="lt2" tx2="dk2" accent1="accent1" accent2="accent2" accent3="accent3" accent4="accent4" accent5="accent5" accent6="accent6" hlink="hlink" folHlink="folHlink"/>
   <p:sldLayoutIdLst>
-    <p:sldLayoutId xmlns:r="http://schemas.openxmlformats.org/officeDocument/2006/relationships" id="2147483649" r:id="Rc0ef8f68268a418d"/>
+    <p:sldLayoutId xmlns:r="http://schemas.openxmlformats.org/officeDocument/2006/relationships" id="2147483649" r:id="R67b432522e384d16"/>
   </p:sldLayoutIdLst>
   <p:txStyles>
     <p:titleStyle>
@@ -1738,7 +1738,7 @@
           <p:cNvPr id="4" name="Title-3-1">
             <a:extLst xmlns:a="http://schemas.openxmlformats.org/drawingml/2006/main">
               <a:ext uri="{FF2B5EF4-FFF2-40B4-BE49-F238E27FC236}">
-                <a16:creationId xmlns:a16="http://schemas.microsoft.com/office/drawing/2014/main" id="{0C16163A-E98B-4251-B7E6-07721E51998B}"/>
+                <a16:creationId xmlns:a16="http://schemas.microsoft.com/office/drawing/2014/main" id="{1AAA42CE-6A04-4C8F-8EE2-F6D64138266F}"/>
               </a:ext>
             </a:extLst>
           </p:cNvPr>
@@ -1796,7 +1796,7 @@
           <p:cNvPr id="2" name="Subtitle-4-2">
             <a:extLst xmlns:a="http://schemas.openxmlformats.org/drawingml/2006/main">
               <a:ext uri="{FF2B5EF4-FFF2-40B4-BE49-F238E27FC236}">
-                <a16:creationId xmlns:a16="http://schemas.microsoft.com/office/drawing/2014/main" id="{3D926490-DC12-483A-A178-0CD75EC9628C}"/>
+                <a16:creationId xmlns:a16="http://schemas.microsoft.com/office/drawing/2014/main" id="{F4CF17E4-0D1D-4DD2-86A3-92DC2156EF81}"/>
               </a:ext>
             </a:extLst>
           </p:cNvPr>
@@ -1853,7 +1853,7 @@
           <p:cNvPr id="3" name="Subtitle-4-3">
             <a:extLst xmlns:a="http://schemas.openxmlformats.org/drawingml/2006/main">
               <a:ext uri="{FF2B5EF4-FFF2-40B4-BE49-F238E27FC236}">
-                <a16:creationId xmlns:a16="http://schemas.microsoft.com/office/drawing/2014/main" id="{58EA7B22-0B08-4BB6-A914-208AC5082CA5}"/>
+                <a16:creationId xmlns:a16="http://schemas.microsoft.com/office/drawing/2014/main" id="{841123D4-C23C-4C92-8BB5-5833B4D0E5EE}"/>
               </a:ext>
             </a:extLst>
           </p:cNvPr>
@@ -1908,7 +1908,7 @@
     </p:spTree>
     <p:extLst>
       <p:ext uri="{BB962C8B-B14F-4D97-AF65-F5344CB8AC3E}">
-        <p14:creationId xmlns:p14="http://schemas.microsoft.com/office/powerpoint/2010/main" val="1336338041"/>
+        <p14:creationId xmlns:p14="http://schemas.microsoft.com/office/powerpoint/2010/main" val="606431021"/>
       </p:ext>
     </p:extLst>
   </p:cSld>
@@ -1929,10 +1929,10 @@
       </p:grpSpPr>
       <p:sp>
         <p:nvSpPr>
-          <p:cNvPr id="4" name="Title-3-1">
+          <p:cNvPr id="5" name="Title-3-1">
             <a:extLst xmlns:a="http://schemas.openxmlformats.org/drawingml/2006/main">
               <a:ext uri="{FF2B5EF4-FFF2-40B4-BE49-F238E27FC236}">
-                <a16:creationId xmlns:a16="http://schemas.microsoft.com/office/drawing/2014/main" id="{04CABB33-3402-4ABB-AA65-58642108F1C2}"/>
+                <a16:creationId xmlns:a16="http://schemas.microsoft.com/office/drawing/2014/main" id="{5038A244-2925-45D0-9B3E-DAE0FC228A41}"/>
               </a:ext>
             </a:extLst>
           </p:cNvPr>
@@ -1979,7 +1979,7 @@
                 <a:ea typeface="Helvetica Neue"/>
                 <a:cs typeface="Helvetica Neue"/>
               </a:rPr>
-              <a:t>Ready for the live demo</a:t>
+              <a:t>Live demo</a:t>
             </a:r>
           </a:p>
         </p:txBody>
@@ -1989,7 +1989,7 @@
           <p:cNvPr id="2" name="Subtitle-4-2">
             <a:extLst xmlns:a="http://schemas.openxmlformats.org/drawingml/2006/main">
               <a:ext uri="{FF2B5EF4-FFF2-40B4-BE49-F238E27FC236}">
-                <a16:creationId xmlns:a16="http://schemas.microsoft.com/office/drawing/2014/main" id="{79C6056C-C14A-4A0E-A703-0B4C3E6CC320}"/>
+                <a16:creationId xmlns:a16="http://schemas.microsoft.com/office/drawing/2014/main" id="{D15A8EE4-E39E-4687-973A-72D5CAB30889}"/>
               </a:ext>
             </a:extLst>
           </p:cNvPr>
@@ -2036,7 +2036,7 @@
                 <a:ea typeface="Helvetica Neue"/>
                 <a:cs typeface="Helvetica Neue"/>
               </a:rPr>
-              <a:t>Register a donor</a:t>
+              <a:t>Review the dashboard</a:t>
             </a:r>
           </a:p>
           <a:p xmlns:a="http://schemas.openxmlformats.org/drawingml/2006/main">
@@ -2063,7 +2063,7 @@
                 <a:ea typeface="Helvetica Neue"/>
                 <a:cs typeface="Helvetica Neue"/>
               </a:rPr>
-              <a:t>Create an emergency request</a:t>
+              <a:t>Process the emergency</a:t>
             </a:r>
           </a:p>
           <a:p xmlns:a="http://schemas.openxmlformats.org/drawingml/2006/main">
@@ -2090,7 +2090,7 @@
                 <a:ea typeface="Helvetica Neue"/>
                 <a:cs typeface="Helvetica Neue"/>
               </a:rPr>
-              <a:t>Match, save, restart</a:t>
+              <a:t>Confirm save + restart</a:t>
             </a:r>
           </a:p>
         </p:txBody>
@@ -2100,7 +2100,7 @@
           <p:cNvPr id="3" name="Subtitle-4-3">
             <a:extLst xmlns:a="http://schemas.openxmlformats.org/drawingml/2006/main">
               <a:ext uri="{FF2B5EF4-FFF2-40B4-BE49-F238E27FC236}">
-                <a16:creationId xmlns:a16="http://schemas.microsoft.com/office/drawing/2014/main" id="{145B1128-468B-41ED-B0ED-DCB45063273B}"/>
+                <a16:creationId xmlns:a16="http://schemas.microsoft.com/office/drawing/2014/main" id="{3782A5B8-EAF5-4B72-8CCF-48454A44B585}"/>
               </a:ext>
             </a:extLst>
           </p:cNvPr>
@@ -2152,10 +2152,34 @@
           </a:p>
         </p:txBody>
       </p:sp>
+      <p:pic>
+        <p:nvPicPr>
+          <p:cNvPr id="8" name=""/>
+          <p:cNvPicPr>
+            <a:picLocks xmlns:a="http://schemas.openxmlformats.org/drawingml/2006/main" noChangeAspect="1"/>
+          </p:cNvPicPr>
+          <p:nvPr/>
+        </p:nvPicPr>
+        <p:blipFill>
+          <a:blip xmlns:r="http://schemas.openxmlformats.org/officeDocument/2006/relationships" xmlns:a="http://schemas.openxmlformats.org/drawingml/2006/main" r:embed="R293d9613b94c4161"/>
+          <a:stretch xmlns:a="http://schemas.openxmlformats.org/drawingml/2006/main"/>
+        </p:blipFill>
+        <p:spPr>
+          <a:xfrm xmlns:a="http://schemas.openxmlformats.org/drawingml/2006/main">
+            <a:off x="6051428" y="876300"/>
+            <a:ext cx="5470769" cy="3333750"/>
+          </a:xfrm>
+          <a:prstGeom xmlns:a="http://schemas.openxmlformats.org/drawingml/2006/main" prst="roundRect">
+            <a:avLst>
+              <a:gd name="adj" fmla="val 3429"/>
+            </a:avLst>
+          </a:prstGeom>
+        </p:spPr>
+      </p:pic>
     </p:spTree>
     <p:extLst>
       <p:ext uri="{BB962C8B-B14F-4D97-AF65-F5344CB8AC3E}">
-        <p14:creationId xmlns:p14="http://schemas.microsoft.com/office/powerpoint/2010/main" val="1098036363"/>
+        <p14:creationId xmlns:p14="http://schemas.microsoft.com/office/powerpoint/2010/main" val="1671873495"/>
       </p:ext>
     </p:extLst>
   </p:cSld>
@@ -2179,7 +2203,7 @@
           <p:cNvPr id="5" name="Google-Shape-534-p58-1">
             <a:extLst xmlns:a="http://schemas.openxmlformats.org/drawingml/2006/main">
               <a:ext uri="{FF2B5EF4-FFF2-40B4-BE49-F238E27FC236}">
-                <a16:creationId xmlns:a16="http://schemas.microsoft.com/office/drawing/2014/main" id="{9B7E0D19-DB1A-4133-95B8-25E07043BC1B}"/>
+                <a16:creationId xmlns:a16="http://schemas.microsoft.com/office/drawing/2014/main" id="{C4E32E90-D501-4012-9D63-4CAA38D10A7B}"/>
               </a:ext>
             </a:extLst>
           </p:cNvPr>
@@ -2329,7 +2353,7 @@
           <p:cNvPr id="2" name="Google-Shape-532-p58-3">
             <a:extLst xmlns:a="http://schemas.openxmlformats.org/drawingml/2006/main">
               <a:ext uri="{FF2B5EF4-FFF2-40B4-BE49-F238E27FC236}">
-                <a16:creationId xmlns:a16="http://schemas.microsoft.com/office/drawing/2014/main" id="{F2A2D555-DB2D-456D-83EA-394C35B5A2EC}"/>
+                <a16:creationId xmlns:a16="http://schemas.microsoft.com/office/drawing/2014/main" id="{9CC2D130-FF44-400B-BDFB-38E7CB1A6D27}"/>
               </a:ext>
             </a:extLst>
           </p:cNvPr>
@@ -2374,7 +2398,7 @@
           <p:cNvPr id="3" name="Google-Shape-533-p58-4">
             <a:extLst xmlns:a="http://schemas.openxmlformats.org/drawingml/2006/main">
               <a:ext uri="{FF2B5EF4-FFF2-40B4-BE49-F238E27FC236}">
-                <a16:creationId xmlns:a16="http://schemas.microsoft.com/office/drawing/2014/main" id="{6408440D-80DF-41CB-8A1E-B528013D8A46}"/>
+                <a16:creationId xmlns:a16="http://schemas.microsoft.com/office/drawing/2014/main" id="{51FA8BC9-D343-4FC1-BAC7-AA85B63D778E}"/>
               </a:ext>
             </a:extLst>
           </p:cNvPr>
@@ -2431,7 +2455,7 @@
           <p:cNvPr id="4" name="Google-Shape-534-p58-5">
             <a:extLst xmlns:a="http://schemas.openxmlformats.org/drawingml/2006/main">
               <a:ext uri="{FF2B5EF4-FFF2-40B4-BE49-F238E27FC236}">
-                <a16:creationId xmlns:a16="http://schemas.microsoft.com/office/drawing/2014/main" id="{C6FC588E-E3F5-4FAF-A218-C01A3CFA8AEE}"/>
+                <a16:creationId xmlns:a16="http://schemas.microsoft.com/office/drawing/2014/main" id="{4528FDEB-9FF9-4E31-9D37-4B089C80FD9E}"/>
               </a:ext>
             </a:extLst>
           </p:cNvPr>
@@ -2549,7 +2573,7 @@
     </p:spTree>
     <p:extLst>
       <p:ext uri="{BB962C8B-B14F-4D97-AF65-F5344CB8AC3E}">
-        <p14:creationId xmlns:p14="http://schemas.microsoft.com/office/powerpoint/2010/main" val="81045817"/>
+        <p14:creationId xmlns:p14="http://schemas.microsoft.com/office/powerpoint/2010/main" val="1737004135"/>
       </p:ext>
     </p:extLst>
   </p:cSld>
@@ -2573,7 +2597,7 @@
           <p:cNvPr id="7" name="Slide-Number-Placeholder-1-2">
             <a:extLst xmlns:a="http://schemas.openxmlformats.org/drawingml/2006/main">
               <a:ext uri="{FF2B5EF4-FFF2-40B4-BE49-F238E27FC236}">
-                <a16:creationId xmlns:a16="http://schemas.microsoft.com/office/drawing/2014/main" id="{0B2079D8-1330-4A98-89C1-F5481F4C6631}"/>
+                <a16:creationId xmlns:a16="http://schemas.microsoft.com/office/drawing/2014/main" id="{9DDB2319-4BF2-4C0A-AC3F-B9EC547348D7}"/>
               </a:ext>
             </a:extLst>
           </p:cNvPr>
@@ -2616,7 +2640,7 @@
           <p:cNvPr id="2" name="Title-2-3">
             <a:extLst xmlns:a="http://schemas.openxmlformats.org/drawingml/2006/main">
               <a:ext uri="{FF2B5EF4-FFF2-40B4-BE49-F238E27FC236}">
-                <a16:creationId xmlns:a16="http://schemas.microsoft.com/office/drawing/2014/main" id="{2B75F521-0DDC-441A-AD50-FCD7EECE73BE}"/>
+                <a16:creationId xmlns:a16="http://schemas.microsoft.com/office/drawing/2014/main" id="{32DE93EB-F8BC-43F1-AF5D-BAF7416B9E7B}"/>
               </a:ext>
             </a:extLst>
           </p:cNvPr>
@@ -2663,7 +2687,7 @@
                 <a:ea typeface="Helvetica Neue"/>
                 <a:cs typeface="Helvetica Neue"/>
               </a:rPr>
-              <a:t>Four objectives define the system</a:t>
+              <a:t>Four pillars define the system</a:t>
             </a:r>
           </a:p>
         </p:txBody>
@@ -2673,7 +2697,7 @@
           <p:cNvPr id="3" name="Content-Placeholder-9-4">
             <a:extLst xmlns:a="http://schemas.openxmlformats.org/drawingml/2006/main">
               <a:ext uri="{FF2B5EF4-FFF2-40B4-BE49-F238E27FC236}">
-                <a16:creationId xmlns:a16="http://schemas.microsoft.com/office/drawing/2014/main" id="{2A55D0FE-8E7A-4285-9F2A-92023D6624FE}"/>
+                <a16:creationId xmlns:a16="http://schemas.microsoft.com/office/drawing/2014/main" id="{5B864AC7-8498-4F04-9896-B24CF1C052B9}"/>
               </a:ext>
             </a:extLst>
           </p:cNvPr>
@@ -2761,7 +2785,7 @@
           <p:cNvPr id="4" name="Content-Placeholder-10-5">
             <a:extLst xmlns:a="http://schemas.openxmlformats.org/drawingml/2006/main">
               <a:ext uri="{FF2B5EF4-FFF2-40B4-BE49-F238E27FC236}">
-                <a16:creationId xmlns:a16="http://schemas.microsoft.com/office/drawing/2014/main" id="{498394F6-17C3-416E-9427-6AA28AF838F8}"/>
+                <a16:creationId xmlns:a16="http://schemas.microsoft.com/office/drawing/2014/main" id="{4558C5C7-DC76-4DBB-9126-5EB48847B5E7}"/>
               </a:ext>
             </a:extLst>
           </p:cNvPr>
@@ -2849,7 +2873,7 @@
           <p:cNvPr id="5" name="Content-Placeholder-9-6">
             <a:extLst xmlns:a="http://schemas.openxmlformats.org/drawingml/2006/main">
               <a:ext uri="{FF2B5EF4-FFF2-40B4-BE49-F238E27FC236}">
-                <a16:creationId xmlns:a16="http://schemas.microsoft.com/office/drawing/2014/main" id="{60B397FA-20AF-451F-BE3E-0565F6755E2C}"/>
+                <a16:creationId xmlns:a16="http://schemas.microsoft.com/office/drawing/2014/main" id="{F2DCB8E8-0E81-4768-B13D-AB3FEDCB76E7}"/>
               </a:ext>
             </a:extLst>
           </p:cNvPr>
@@ -2939,7 +2963,7 @@
           <p:cNvPr id="6" name="Content-Placeholder-10-7">
             <a:extLst xmlns:a="http://schemas.openxmlformats.org/drawingml/2006/main">
               <a:ext uri="{FF2B5EF4-FFF2-40B4-BE49-F238E27FC236}">
-                <a16:creationId xmlns:a16="http://schemas.microsoft.com/office/drawing/2014/main" id="{0555053F-1848-4655-BFF9-2C81A92CC34F}"/>
+                <a16:creationId xmlns:a16="http://schemas.microsoft.com/office/drawing/2014/main" id="{B4DFA9E4-86EF-4A99-B50E-887ED0440C47}"/>
               </a:ext>
             </a:extLst>
           </p:cNvPr>
@@ -2989,7 +3013,7 @@
                 <a:ea typeface="Helvetica Neue"/>
                 <a:cs typeface="Helvetica Neue"/>
               </a:rPr>
-              <a:t>04  Persistence</a:t>
+              <a:t>04  Dashboard + UX</a:t>
             </a:r>
           </a:p>
           <a:p xmlns:a="http://schemas.openxmlformats.org/drawingml/2006/main">
@@ -3019,7 +3043,7 @@
                 <a:ea typeface="Helvetica Neue"/>
                 <a:cs typeface="Helvetica Neue"/>
               </a:rPr>
-              <a:t>Save donors, units, and polymorphic requests in clear pipe-delimited files.</a:t>
+              <a:t>Expose live stock, urgent demand, quick actions, and safe editing in one clear interface.</a:t>
             </a:r>
           </a:p>
         </p:txBody>
@@ -3027,7 +3051,7 @@
     </p:spTree>
     <p:extLst>
       <p:ext uri="{BB962C8B-B14F-4D97-AF65-F5344CB8AC3E}">
-        <p14:creationId xmlns:p14="http://schemas.microsoft.com/office/powerpoint/2010/main" val="1462143543"/>
+        <p14:creationId xmlns:p14="http://schemas.microsoft.com/office/powerpoint/2010/main" val="973100786"/>
       </p:ext>
     </p:extLst>
   </p:cSld>
@@ -3051,7 +3075,7 @@
           <p:cNvPr id="13" name="Slide-Number-Placeholder-3-2">
             <a:extLst xmlns:a="http://schemas.openxmlformats.org/drawingml/2006/main">
               <a:ext uri="{FF2B5EF4-FFF2-40B4-BE49-F238E27FC236}">
-                <a16:creationId xmlns:a16="http://schemas.microsoft.com/office/drawing/2014/main" id="{610FAB9B-09AB-4AAB-821B-93332247EAB6}"/>
+                <a16:creationId xmlns:a16="http://schemas.microsoft.com/office/drawing/2014/main" id="{C1614FFB-3C65-4E0C-B266-959D15B25590}"/>
               </a:ext>
             </a:extLst>
           </p:cNvPr>
@@ -3094,7 +3118,7 @@
           <p:cNvPr id="2" name="Title-10-3">
             <a:extLst xmlns:a="http://schemas.openxmlformats.org/drawingml/2006/main">
               <a:ext uri="{FF2B5EF4-FFF2-40B4-BE49-F238E27FC236}">
-                <a16:creationId xmlns:a16="http://schemas.microsoft.com/office/drawing/2014/main" id="{2F79BFD2-832C-4E53-8DE3-B22D777562E9}"/>
+                <a16:creationId xmlns:a16="http://schemas.microsoft.com/office/drawing/2014/main" id="{C09189E5-1644-4AC8-A386-D749D3D0F574}"/>
               </a:ext>
             </a:extLst>
           </p:cNvPr>
@@ -3141,7 +3165,7 @@
                 <a:ea typeface="Helvetica Neue"/>
                 <a:cs typeface="Helvetica Neue"/>
               </a:rPr>
-              <a:t>One workflow connects all four tabs</a:t>
+              <a:t>One dashboard guides the complete workflow</a:t>
             </a:r>
           </a:p>
         </p:txBody>
@@ -3173,7 +3197,7 @@
           <p:cNvPr id="4" name="Google-Shape-2260-p159-5">
             <a:extLst xmlns:a="http://schemas.openxmlformats.org/drawingml/2006/main">
               <a:ext uri="{FF2B5EF4-FFF2-40B4-BE49-F238E27FC236}">
-                <a16:creationId xmlns:a16="http://schemas.microsoft.com/office/drawing/2014/main" id="{4DCFC57E-A677-457F-9333-C7CD624CFB5F}"/>
+                <a16:creationId xmlns:a16="http://schemas.microsoft.com/office/drawing/2014/main" id="{972BEECD-6B83-49A2-AAF6-2A8A8859FFBD}"/>
               </a:ext>
             </a:extLst>
           </p:cNvPr>
@@ -3200,7 +3224,7 @@
           <p:cNvPr id="5" name="Google-Shape-2261-p159-6">
             <a:extLst xmlns:a="http://schemas.openxmlformats.org/drawingml/2006/main">
               <a:ext uri="{FF2B5EF4-FFF2-40B4-BE49-F238E27FC236}">
-                <a16:creationId xmlns:a16="http://schemas.microsoft.com/office/drawing/2014/main" id="{26D1140C-5A5C-4C35-ADF3-8DA7B95F2F69}"/>
+                <a16:creationId xmlns:a16="http://schemas.microsoft.com/office/drawing/2014/main" id="{C1A353DA-10D0-4082-844A-59ED5F8CD9F7}"/>
               </a:ext>
             </a:extLst>
           </p:cNvPr>
@@ -3227,7 +3251,7 @@
           <p:cNvPr id="6" name="Google-Shape-2262-p159-7">
             <a:extLst xmlns:a="http://schemas.openxmlformats.org/drawingml/2006/main">
               <a:ext uri="{FF2B5EF4-FFF2-40B4-BE49-F238E27FC236}">
-                <a16:creationId xmlns:a16="http://schemas.microsoft.com/office/drawing/2014/main" id="{D623BC45-CD61-4431-B4BE-794D5A960F2A}"/>
+                <a16:creationId xmlns:a16="http://schemas.microsoft.com/office/drawing/2014/main" id="{2E145008-2706-421A-9F4F-B9D8EF866183}"/>
               </a:ext>
             </a:extLst>
           </p:cNvPr>
@@ -3254,7 +3278,7 @@
           <p:cNvPr id="7" name="Content-Placeholder-15-8">
             <a:extLst xmlns:a="http://schemas.openxmlformats.org/drawingml/2006/main">
               <a:ext uri="{FF2B5EF4-FFF2-40B4-BE49-F238E27FC236}">
-                <a16:creationId xmlns:a16="http://schemas.microsoft.com/office/drawing/2014/main" id="{97CF8D6E-2CBA-4032-8883-D468A0B62677}"/>
+                <a16:creationId xmlns:a16="http://schemas.microsoft.com/office/drawing/2014/main" id="{B4D36A10-8E33-4F32-90E4-8BC3E5DC84AF}"/>
               </a:ext>
             </a:extLst>
           </p:cNvPr>
@@ -3301,7 +3325,7 @@
                 <a:ea typeface="Helvetica Neue"/>
                 <a:cs typeface="Helvetica Neue"/>
               </a:rPr>
-              <a:t>REGISTER</a:t>
+              <a:t>SEE STATUS</a:t>
             </a:r>
           </a:p>
         </p:txBody>
@@ -3311,7 +3335,7 @@
           <p:cNvPr id="8" name="Content-Placeholder-15-9">
             <a:extLst xmlns:a="http://schemas.openxmlformats.org/drawingml/2006/main">
               <a:ext uri="{FF2B5EF4-FFF2-40B4-BE49-F238E27FC236}">
-                <a16:creationId xmlns:a16="http://schemas.microsoft.com/office/drawing/2014/main" id="{C7557603-5D12-405C-9F34-55530334E65D}"/>
+                <a16:creationId xmlns:a16="http://schemas.microsoft.com/office/drawing/2014/main" id="{EB1C23E5-DB19-4580-9FC3-DA9A95BD0466}"/>
               </a:ext>
             </a:extLst>
           </p:cNvPr>
@@ -3358,7 +3382,7 @@
                 <a:ea typeface="Helvetica Neue"/>
                 <a:cs typeface="Helvetica Neue"/>
               </a:rPr>
-              <a:t>PRIORITIZE</a:t>
+              <a:t>ACT</a:t>
             </a:r>
           </a:p>
         </p:txBody>
@@ -3368,7 +3392,7 @@
           <p:cNvPr id="9" name="Content-Placeholder-15-10">
             <a:extLst xmlns:a="http://schemas.openxmlformats.org/drawingml/2006/main">
               <a:ext uri="{FF2B5EF4-FFF2-40B4-BE49-F238E27FC236}">
-                <a16:creationId xmlns:a16="http://schemas.microsoft.com/office/drawing/2014/main" id="{00C0D8A0-53D4-4159-91E9-F636AC28820A}"/>
+                <a16:creationId xmlns:a16="http://schemas.microsoft.com/office/drawing/2014/main" id="{2575AE2D-D916-4CC0-AD12-A46659E5377F}"/>
               </a:ext>
             </a:extLst>
           </p:cNvPr>
@@ -3425,7 +3449,7 @@
           <p:cNvPr id="10" name="Text-Placeholder-16-11">
             <a:extLst xmlns:a="http://schemas.openxmlformats.org/drawingml/2006/main">
               <a:ext uri="{FF2B5EF4-FFF2-40B4-BE49-F238E27FC236}">
-                <a16:creationId xmlns:a16="http://schemas.microsoft.com/office/drawing/2014/main" id="{F9921C23-57E7-40C6-B68E-C6119CBB72DF}"/>
+                <a16:creationId xmlns:a16="http://schemas.microsoft.com/office/drawing/2014/main" id="{9A46FC97-CB55-4EB8-8C76-470C417C845F}"/>
               </a:ext>
             </a:extLst>
           </p:cNvPr>
@@ -3475,7 +3499,7 @@
                 <a:ea typeface="Helvetica Neue"/>
                 <a:cs typeface="Helvetica Neue"/>
               </a:rPr>
-              <a:t>Queued requests</a:t>
+              <a:t>Focused quick actions</a:t>
             </a:r>
           </a:p>
           <a:p xmlns:a="http://schemas.openxmlformats.org/drawingml/2006/main">
@@ -3505,7 +3529,7 @@
                 <a:ea typeface="Helvetica Neue"/>
                 <a:cs typeface="Helvetica Neue"/>
               </a:rPr>
-              <a:t>Store both request subclasses in ArrayList&lt;BloodRequest&gt;.</a:t>
+              <a:t>Open a clean add dialog for donors, units, or requests without leaving the dashboard.</a:t>
             </a:r>
           </a:p>
         </p:txBody>
@@ -3515,7 +3539,7 @@
           <p:cNvPr id="11" name="Text-Placeholder-16-12">
             <a:extLst xmlns:a="http://schemas.openxmlformats.org/drawingml/2006/main">
               <a:ext uri="{FF2B5EF4-FFF2-40B4-BE49-F238E27FC236}">
-                <a16:creationId xmlns:a16="http://schemas.microsoft.com/office/drawing/2014/main" id="{7A7071CD-DB9A-44D8-824A-DC53DEC1DA7A}"/>
+                <a16:creationId xmlns:a16="http://schemas.microsoft.com/office/drawing/2014/main" id="{0EA38D6B-C236-4B05-BB24-201B12B66B80}"/>
               </a:ext>
             </a:extLst>
           </p:cNvPr>
@@ -3565,7 +3589,7 @@
                 <a:ea typeface="Helvetica Neue"/>
                 <a:cs typeface="Helvetica Neue"/>
               </a:rPr>
-              <a:t>Donors + units</a:t>
+              <a:t>Live operational view</a:t>
             </a:r>
           </a:p>
           <a:p xmlns:a="http://schemas.openxmlformats.org/drawingml/2006/main">
@@ -3595,7 +3619,7 @@
                 <a:ea typeface="Helvetica Neue"/>
                 <a:cs typeface="Helvetica Neue"/>
               </a:rPr>
-              <a:t>Validate the donor, create a blood unit, and refresh the inventory summary.</a:t>
+              <a:t>Review donors, available stock, pending requests, and the emergency queue at startup.</a:t>
             </a:r>
           </a:p>
         </p:txBody>
@@ -3605,7 +3629,7 @@
           <p:cNvPr id="12" name="Text-Placeholder-16-13">
             <a:extLst xmlns:a="http://schemas.openxmlformats.org/drawingml/2006/main">
               <a:ext uri="{FF2B5EF4-FFF2-40B4-BE49-F238E27FC236}">
-                <a16:creationId xmlns:a16="http://schemas.microsoft.com/office/drawing/2014/main" id="{0E021720-6F0B-41D1-A77C-9F716234E97A}"/>
+                <a16:creationId xmlns:a16="http://schemas.microsoft.com/office/drawing/2014/main" id="{EC9FE96E-CB50-4544-AA2B-7016916C4172}"/>
               </a:ext>
             </a:extLst>
           </p:cNvPr>
@@ -3693,7 +3717,7 @@
     </p:spTree>
     <p:extLst>
       <p:ext uri="{BB962C8B-B14F-4D97-AF65-F5344CB8AC3E}">
-        <p14:creationId xmlns:p14="http://schemas.microsoft.com/office/powerpoint/2010/main" val="1864429944"/>
+        <p14:creationId xmlns:p14="http://schemas.microsoft.com/office/powerpoint/2010/main" val="1835765856"/>
       </p:ext>
     </p:extLst>
   </p:cSld>
@@ -3717,7 +3741,7 @@
           <p:cNvPr id="6" name="Google-Shape-532-p58-2">
             <a:extLst xmlns:a="http://schemas.openxmlformats.org/drawingml/2006/main">
               <a:ext uri="{FF2B5EF4-FFF2-40B4-BE49-F238E27FC236}">
-                <a16:creationId xmlns:a16="http://schemas.microsoft.com/office/drawing/2014/main" id="{65986B07-86B7-4450-9054-A8CC3EC40133}"/>
+                <a16:creationId xmlns:a16="http://schemas.microsoft.com/office/drawing/2014/main" id="{4BB71286-CF1E-40EA-92A9-FA478326E882}"/>
               </a:ext>
             </a:extLst>
           </p:cNvPr>
@@ -3762,7 +3786,7 @@
           <p:cNvPr id="2" name="Google-Shape-533-p58-3">
             <a:extLst xmlns:a="http://schemas.openxmlformats.org/drawingml/2006/main">
               <a:ext uri="{FF2B5EF4-FFF2-40B4-BE49-F238E27FC236}">
-                <a16:creationId xmlns:a16="http://schemas.microsoft.com/office/drawing/2014/main" id="{D1AE3B9A-74CF-46C6-9E09-1DE95865CD8B}"/>
+                <a16:creationId xmlns:a16="http://schemas.microsoft.com/office/drawing/2014/main" id="{19B6DBFE-6688-4502-812B-D74424B7B8BC}"/>
               </a:ext>
             </a:extLst>
           </p:cNvPr>
@@ -3819,7 +3843,7 @@
           <p:cNvPr id="3" name="Google-Shape-534-p58-4">
             <a:extLst xmlns:a="http://schemas.openxmlformats.org/drawingml/2006/main">
               <a:ext uri="{FF2B5EF4-FFF2-40B4-BE49-F238E27FC236}">
-                <a16:creationId xmlns:a16="http://schemas.microsoft.com/office/drawing/2014/main" id="{3537BAA4-CD43-4EAC-8875-B03BE32C1C26}"/>
+                <a16:creationId xmlns:a16="http://schemas.microsoft.com/office/drawing/2014/main" id="{DD471BCD-58E8-4310-8B0C-EA17C3DD2A86}"/>
               </a:ext>
             </a:extLst>
           </p:cNvPr>
@@ -3899,9 +3923,9 @@
                 <a:ea typeface="Helvetica Neue"/>
                 <a:cs typeface="Helvetica Neue"/>
               </a:rPr>
-              <a:t>LifeFlowFrame
-Four Swing tabs
-JOptionPane validation</a:t>
+              <a:t>Sidebar + CardLayout
+Five focused panels
+Reusable UI theme</a:t>
             </a:r>
           </a:p>
         </p:txBody>
@@ -3911,7 +3935,7 @@
           <p:cNvPr id="4" name="Content-Placeholder-1-5">
             <a:extLst xmlns:a="http://schemas.openxmlformats.org/drawingml/2006/main">
               <a:ext uri="{FF2B5EF4-FFF2-40B4-BE49-F238E27FC236}">
-                <a16:creationId xmlns:a16="http://schemas.microsoft.com/office/drawing/2014/main" id="{71B3AD5B-4E52-4E68-81A0-6F153FA51C1D}"/>
+                <a16:creationId xmlns:a16="http://schemas.microsoft.com/office/drawing/2014/main" id="{3A2F669F-4337-4A1A-ACEE-FE63C4B2138C}"/>
               </a:ext>
             </a:extLst>
           </p:cNvPr>
@@ -4003,7 +4027,7 @@
           <p:cNvPr id="5" name="Content-Placeholder-2-6">
             <a:extLst xmlns:a="http://schemas.openxmlformats.org/drawingml/2006/main">
               <a:ext uri="{FF2B5EF4-FFF2-40B4-BE49-F238E27FC236}">
-                <a16:creationId xmlns:a16="http://schemas.microsoft.com/office/drawing/2014/main" id="{68C6722F-5A77-4EF5-9F80-FA6BDB0442F5}"/>
+                <a16:creationId xmlns:a16="http://schemas.microsoft.com/office/drawing/2014/main" id="{50479CB0-22F0-41D0-AA61-95FB4DA9F4CA}"/>
               </a:ext>
             </a:extLst>
           </p:cNvPr>
@@ -4053,7 +4077,7 @@
                 <a:ea typeface="Helvetica Neue"/>
                 <a:cs typeface="Helvetica Neue"/>
               </a:rPr>
-              <a:t>Domain + services</a:t>
+              <a:t>Controller + domain</a:t>
             </a:r>
           </a:p>
           <a:p xmlns:a="http://schemas.openxmlformats.org/drawingml/2006/main">
@@ -4083,7 +4107,7 @@
                 <a:ea typeface="Helvetica Neue"/>
                 <a:cs typeface="Helvetica Neue"/>
               </a:rPr>
-              <a:t>Donor and BloodUnit
+              <a:t>LifeFlowController
 Request hierarchy
 Inventory + matching</a:t>
             </a:r>
@@ -4093,7 +4117,7 @@
     </p:spTree>
     <p:extLst>
       <p:ext uri="{BB962C8B-B14F-4D97-AF65-F5344CB8AC3E}">
-        <p14:creationId xmlns:p14="http://schemas.microsoft.com/office/powerpoint/2010/main" val="370873436"/>
+        <p14:creationId xmlns:p14="http://schemas.microsoft.com/office/powerpoint/2010/main" val="1840253044"/>
       </p:ext>
     </p:extLst>
   </p:cSld>
@@ -4117,7 +4141,7 @@
           <p:cNvPr id="10" name="Google-Shape-532-p58-2">
             <a:extLst xmlns:a="http://schemas.openxmlformats.org/drawingml/2006/main">
               <a:ext uri="{FF2B5EF4-FFF2-40B4-BE49-F238E27FC236}">
-                <a16:creationId xmlns:a16="http://schemas.microsoft.com/office/drawing/2014/main" id="{A7513D11-D520-4B82-B116-3ED9D8B90160}"/>
+                <a16:creationId xmlns:a16="http://schemas.microsoft.com/office/drawing/2014/main" id="{AAB61A84-A7D9-4AD4-8768-E899EB693866}"/>
               </a:ext>
             </a:extLst>
           </p:cNvPr>
@@ -4162,7 +4186,7 @@
           <p:cNvPr id="2" name="Google-Shape-533-p58-3">
             <a:extLst xmlns:a="http://schemas.openxmlformats.org/drawingml/2006/main">
               <a:ext uri="{FF2B5EF4-FFF2-40B4-BE49-F238E27FC236}">
-                <a16:creationId xmlns:a16="http://schemas.microsoft.com/office/drawing/2014/main" id="{2A6EC82E-64BB-4058-93DE-296834014232}"/>
+                <a16:creationId xmlns:a16="http://schemas.microsoft.com/office/drawing/2014/main" id="{3149B709-DEEF-46F5-831A-E82FF0A601FD}"/>
               </a:ext>
             </a:extLst>
           </p:cNvPr>
@@ -4219,7 +4243,7 @@
           <p:cNvPr id="3" name="Rounded-Rectangle-1-4">
             <a:extLst xmlns:a="http://schemas.openxmlformats.org/drawingml/2006/main">
               <a:ext uri="{FF2B5EF4-FFF2-40B4-BE49-F238E27FC236}">
-                <a16:creationId xmlns:a16="http://schemas.microsoft.com/office/drawing/2014/main" id="{E170359C-74A3-4053-9532-D99E97FC7B6C}"/>
+                <a16:creationId xmlns:a16="http://schemas.microsoft.com/office/drawing/2014/main" id="{D7789CC6-294B-4F61-8372-64C90D65C250}"/>
               </a:ext>
             </a:extLst>
           </p:cNvPr>
@@ -4248,7 +4272,7 @@
           <p:cNvPr id="4" name="Content-Placeholder-10-5">
             <a:extLst xmlns:a="http://schemas.openxmlformats.org/drawingml/2006/main">
               <a:ext uri="{FF2B5EF4-FFF2-40B4-BE49-F238E27FC236}">
-                <a16:creationId xmlns:a16="http://schemas.microsoft.com/office/drawing/2014/main" id="{96AC6E27-87FA-44D5-9C7A-7D212D3AA53F}"/>
+                <a16:creationId xmlns:a16="http://schemas.microsoft.com/office/drawing/2014/main" id="{643A7E01-3C4D-462E-B9EC-6A4F784D1F90}"/>
               </a:ext>
             </a:extLst>
           </p:cNvPr>
@@ -4305,7 +4329,7 @@
           <p:cNvPr id="5" name="Content-Placeholder-15-6">
             <a:extLst xmlns:a="http://schemas.openxmlformats.org/drawingml/2006/main">
               <a:ext uri="{FF2B5EF4-FFF2-40B4-BE49-F238E27FC236}">
-                <a16:creationId xmlns:a16="http://schemas.microsoft.com/office/drawing/2014/main" id="{FDA8DD58-84CD-450B-8E4B-81145B597F7B}"/>
+                <a16:creationId xmlns:a16="http://schemas.microsoft.com/office/drawing/2014/main" id="{D6892B67-9014-4EAA-A7FD-F8C3603E0893}"/>
               </a:ext>
             </a:extLst>
           </p:cNvPr>
@@ -4425,7 +4449,7 @@
           <p:cNvPr id="6" name="Rounded-Rectangle-7-7">
             <a:extLst xmlns:a="http://schemas.openxmlformats.org/drawingml/2006/main">
               <a:ext uri="{FF2B5EF4-FFF2-40B4-BE49-F238E27FC236}">
-                <a16:creationId xmlns:a16="http://schemas.microsoft.com/office/drawing/2014/main" id="{51ECC5CC-CCEF-49E6-A657-FEAC8A672182}"/>
+                <a16:creationId xmlns:a16="http://schemas.microsoft.com/office/drawing/2014/main" id="{A0390DA1-E0A6-4CC2-85F0-3CE16D0CA198}"/>
               </a:ext>
             </a:extLst>
           </p:cNvPr>
@@ -4454,7 +4478,7 @@
           <p:cNvPr id="7" name="Content-Placeholder-10-8">
             <a:extLst xmlns:a="http://schemas.openxmlformats.org/drawingml/2006/main">
               <a:ext uri="{FF2B5EF4-FFF2-40B4-BE49-F238E27FC236}">
-                <a16:creationId xmlns:a16="http://schemas.microsoft.com/office/drawing/2014/main" id="{88F4DBE3-D36F-484B-B136-78A57AC868F2}"/>
+                <a16:creationId xmlns:a16="http://schemas.microsoft.com/office/drawing/2014/main" id="{67276B94-FF98-442C-A299-F485B34C73C1}"/>
               </a:ext>
             </a:extLst>
           </p:cNvPr>
@@ -4511,7 +4535,7 @@
           <p:cNvPr id="8" name="Content-Placeholder-15-9">
             <a:extLst xmlns:a="http://schemas.openxmlformats.org/drawingml/2006/main">
               <a:ext uri="{FF2B5EF4-FFF2-40B4-BE49-F238E27FC236}">
-                <a16:creationId xmlns:a16="http://schemas.microsoft.com/office/drawing/2014/main" id="{6D9AA0D2-D908-4D32-A843-42B284BEADD9}"/>
+                <a16:creationId xmlns:a16="http://schemas.microsoft.com/office/drawing/2014/main" id="{AFFC8B61-3767-442B-B633-EE53BC28B8CF}"/>
               </a:ext>
             </a:extLst>
           </p:cNvPr>
@@ -4631,7 +4655,7 @@
           <p:cNvPr id="9" name="Content-Placeholder-15-10">
             <a:extLst xmlns:a="http://schemas.openxmlformats.org/drawingml/2006/main">
               <a:ext uri="{FF2B5EF4-FFF2-40B4-BE49-F238E27FC236}">
-                <a16:creationId xmlns:a16="http://schemas.microsoft.com/office/drawing/2014/main" id="{51DF1229-C634-465B-AB16-BDE7DBEA3C57}"/>
+                <a16:creationId xmlns:a16="http://schemas.microsoft.com/office/drawing/2014/main" id="{F3F8525B-4E23-46EE-B710-76C20F6248DC}"/>
               </a:ext>
             </a:extLst>
           </p:cNvPr>
@@ -4749,7 +4773,7 @@
     </p:spTree>
     <p:extLst>
       <p:ext uri="{BB962C8B-B14F-4D97-AF65-F5344CB8AC3E}">
-        <p14:creationId xmlns:p14="http://schemas.microsoft.com/office/powerpoint/2010/main" val="338435290"/>
+        <p14:creationId xmlns:p14="http://schemas.microsoft.com/office/powerpoint/2010/main" val="1343944864"/>
       </p:ext>
     </p:extLst>
   </p:cSld>
@@ -4773,7 +4797,7 @@
           <p:cNvPr id="5" name="Google-Shape-534-p58-1">
             <a:extLst xmlns:a="http://schemas.openxmlformats.org/drawingml/2006/main">
               <a:ext uri="{FF2B5EF4-FFF2-40B4-BE49-F238E27FC236}">
-                <a16:creationId xmlns:a16="http://schemas.microsoft.com/office/drawing/2014/main" id="{E77BD2DF-97E4-4063-BF01-E519A537A2AB}"/>
+                <a16:creationId xmlns:a16="http://schemas.microsoft.com/office/drawing/2014/main" id="{DA1BC0E1-506C-4A9F-8BBD-86890CE2BAFB}"/>
               </a:ext>
             </a:extLst>
           </p:cNvPr>
@@ -4923,7 +4947,7 @@
           <p:cNvPr id="2" name="Google-Shape-532-p58-3">
             <a:extLst xmlns:a="http://schemas.openxmlformats.org/drawingml/2006/main">
               <a:ext uri="{FF2B5EF4-FFF2-40B4-BE49-F238E27FC236}">
-                <a16:creationId xmlns:a16="http://schemas.microsoft.com/office/drawing/2014/main" id="{6EDDA364-7A13-489C-A77B-52D5071D5D06}"/>
+                <a16:creationId xmlns:a16="http://schemas.microsoft.com/office/drawing/2014/main" id="{4D9E6949-3A95-40D1-B442-F97272815E7F}"/>
               </a:ext>
             </a:extLst>
           </p:cNvPr>
@@ -4968,7 +4992,7 @@
           <p:cNvPr id="3" name="Google-Shape-533-p58-4">
             <a:extLst xmlns:a="http://schemas.openxmlformats.org/drawingml/2006/main">
               <a:ext uri="{FF2B5EF4-FFF2-40B4-BE49-F238E27FC236}">
-                <a16:creationId xmlns:a16="http://schemas.microsoft.com/office/drawing/2014/main" id="{ADC941C0-F85C-44D9-9DE1-48FE6285897C}"/>
+                <a16:creationId xmlns:a16="http://schemas.microsoft.com/office/drawing/2014/main" id="{FDF444BC-C903-408A-818E-FBC9410701E7}"/>
               </a:ext>
             </a:extLst>
           </p:cNvPr>
@@ -5025,7 +5049,7 @@
           <p:cNvPr id="4" name="Google-Shape-534-p58-5">
             <a:extLst xmlns:a="http://schemas.openxmlformats.org/drawingml/2006/main">
               <a:ext uri="{FF2B5EF4-FFF2-40B4-BE49-F238E27FC236}">
-                <a16:creationId xmlns:a16="http://schemas.microsoft.com/office/drawing/2014/main" id="{B0CE959E-BD9C-4339-A5B5-B2CB34AC1C09}"/>
+                <a16:creationId xmlns:a16="http://schemas.microsoft.com/office/drawing/2014/main" id="{AAF56DCF-A65E-4A98-8A80-52D0C74B895B}"/>
               </a:ext>
             </a:extLst>
           </p:cNvPr>
@@ -5143,7 +5167,7 @@
     </p:spTree>
     <p:extLst>
       <p:ext uri="{BB962C8B-B14F-4D97-AF65-F5344CB8AC3E}">
-        <p14:creationId xmlns:p14="http://schemas.microsoft.com/office/powerpoint/2010/main" val="562543175"/>
+        <p14:creationId xmlns:p14="http://schemas.microsoft.com/office/powerpoint/2010/main" val="1357754841"/>
       </p:ext>
     </p:extLst>
   </p:cSld>
@@ -5167,7 +5191,7 @@
           <p:cNvPr id="7" name="Slide-Number-Placeholder-1-2">
             <a:extLst xmlns:a="http://schemas.openxmlformats.org/drawingml/2006/main">
               <a:ext uri="{FF2B5EF4-FFF2-40B4-BE49-F238E27FC236}">
-                <a16:creationId xmlns:a16="http://schemas.microsoft.com/office/drawing/2014/main" id="{184C1760-E2EB-47C2-89B9-3AE723F7872E}"/>
+                <a16:creationId xmlns:a16="http://schemas.microsoft.com/office/drawing/2014/main" id="{E1F43992-2154-4253-B022-0F73E3E7FDCD}"/>
               </a:ext>
             </a:extLst>
           </p:cNvPr>
@@ -5210,7 +5234,7 @@
           <p:cNvPr id="2" name="Title-2-3">
             <a:extLst xmlns:a="http://schemas.openxmlformats.org/drawingml/2006/main">
               <a:ext uri="{FF2B5EF4-FFF2-40B4-BE49-F238E27FC236}">
-                <a16:creationId xmlns:a16="http://schemas.microsoft.com/office/drawing/2014/main" id="{7626AFFB-F592-4942-9740-64A1A93221ED}"/>
+                <a16:creationId xmlns:a16="http://schemas.microsoft.com/office/drawing/2014/main" id="{B40DBFF3-96EF-4B2A-A8DC-8EFFC260676D}"/>
               </a:ext>
             </a:extLst>
           </p:cNvPr>
@@ -5267,7 +5291,7 @@
           <p:cNvPr id="3" name="Content-Placeholder-9-4">
             <a:extLst xmlns:a="http://schemas.openxmlformats.org/drawingml/2006/main">
               <a:ext uri="{FF2B5EF4-FFF2-40B4-BE49-F238E27FC236}">
-                <a16:creationId xmlns:a16="http://schemas.microsoft.com/office/drawing/2014/main" id="{818E9E92-DE55-4443-8FDA-F9F7FE9506AA}"/>
+                <a16:creationId xmlns:a16="http://schemas.microsoft.com/office/drawing/2014/main" id="{B67717B8-C7D3-4415-828A-D2C61C271AD4}"/>
               </a:ext>
             </a:extLst>
           </p:cNvPr>
@@ -5355,7 +5379,7 @@
           <p:cNvPr id="4" name="Content-Placeholder-10-5">
             <a:extLst xmlns:a="http://schemas.openxmlformats.org/drawingml/2006/main">
               <a:ext uri="{FF2B5EF4-FFF2-40B4-BE49-F238E27FC236}">
-                <a16:creationId xmlns:a16="http://schemas.microsoft.com/office/drawing/2014/main" id="{72349004-C7E5-49C1-88B3-32392E508535}"/>
+                <a16:creationId xmlns:a16="http://schemas.microsoft.com/office/drawing/2014/main" id="{63E7DB29-5716-4DDA-8F47-9182A194044C}"/>
               </a:ext>
             </a:extLst>
           </p:cNvPr>
@@ -5443,7 +5467,7 @@
           <p:cNvPr id="5" name="Content-Placeholder-9-6">
             <a:extLst xmlns:a="http://schemas.openxmlformats.org/drawingml/2006/main">
               <a:ext uri="{FF2B5EF4-FFF2-40B4-BE49-F238E27FC236}">
-                <a16:creationId xmlns:a16="http://schemas.microsoft.com/office/drawing/2014/main" id="{8A0E5865-3CBD-48E0-BF9E-44C4394A5250}"/>
+                <a16:creationId xmlns:a16="http://schemas.microsoft.com/office/drawing/2014/main" id="{156A02E1-68E3-4366-B82F-1535B3155C57}"/>
               </a:ext>
             </a:extLst>
           </p:cNvPr>
@@ -5533,7 +5557,7 @@
           <p:cNvPr id="6" name="Content-Placeholder-10-7">
             <a:extLst xmlns:a="http://schemas.openxmlformats.org/drawingml/2006/main">
               <a:ext uri="{FF2B5EF4-FFF2-40B4-BE49-F238E27FC236}">
-                <a16:creationId xmlns:a16="http://schemas.microsoft.com/office/drawing/2014/main" id="{379B2859-7A65-4420-831A-9AA94111BFA4}"/>
+                <a16:creationId xmlns:a16="http://schemas.microsoft.com/office/drawing/2014/main" id="{E71B853D-4AFD-4B69-81C5-77E6C16697CC}"/>
               </a:ext>
             </a:extLst>
           </p:cNvPr>
@@ -5621,7 +5645,7 @@
     </p:spTree>
     <p:extLst>
       <p:ext uri="{BB962C8B-B14F-4D97-AF65-F5344CB8AC3E}">
-        <p14:creationId xmlns:p14="http://schemas.microsoft.com/office/powerpoint/2010/main" val="1938943371"/>
+        <p14:creationId xmlns:p14="http://schemas.microsoft.com/office/powerpoint/2010/main" val="53052679"/>
       </p:ext>
     </p:extLst>
   </p:cSld>
@@ -5645,7 +5669,7 @@
           <p:cNvPr id="13" name="Rounded-Rectangle-5-1">
             <a:extLst xmlns:a="http://schemas.openxmlformats.org/drawingml/2006/main">
               <a:ext uri="{FF2B5EF4-FFF2-40B4-BE49-F238E27FC236}">
-                <a16:creationId xmlns:a16="http://schemas.microsoft.com/office/drawing/2014/main" id="{0AAB6BFE-898C-403D-9D2F-75C9709CA938}"/>
+                <a16:creationId xmlns:a16="http://schemas.microsoft.com/office/drawing/2014/main" id="{CE942789-AE95-452A-9654-78A6D4D92AE7}"/>
               </a:ext>
             </a:extLst>
           </p:cNvPr>
@@ -5674,7 +5698,7 @@
           <p:cNvPr id="2" name="Rounded-Rectangle-6-2">
             <a:extLst xmlns:a="http://schemas.openxmlformats.org/drawingml/2006/main">
               <a:ext uri="{FF2B5EF4-FFF2-40B4-BE49-F238E27FC236}">
-                <a16:creationId xmlns:a16="http://schemas.microsoft.com/office/drawing/2014/main" id="{3FC00FDD-603C-4495-A880-64591EA43C20}"/>
+                <a16:creationId xmlns:a16="http://schemas.microsoft.com/office/drawing/2014/main" id="{E27D1B19-8DCC-4E78-8943-964DE1A6E3C1}"/>
               </a:ext>
             </a:extLst>
           </p:cNvPr>
@@ -5703,7 +5727,7 @@
           <p:cNvPr id="3" name="Rounded-Rectangle-7-3">
             <a:extLst xmlns:a="http://schemas.openxmlformats.org/drawingml/2006/main">
               <a:ext uri="{FF2B5EF4-FFF2-40B4-BE49-F238E27FC236}">
-                <a16:creationId xmlns:a16="http://schemas.microsoft.com/office/drawing/2014/main" id="{662F9595-E598-4A91-B562-B0D4FD707DA2}"/>
+                <a16:creationId xmlns:a16="http://schemas.microsoft.com/office/drawing/2014/main" id="{68E6106E-CCBA-44D6-ADFB-6C3CB934AEAC}"/>
               </a:ext>
             </a:extLst>
           </p:cNvPr>
@@ -5732,7 +5756,7 @@
           <p:cNvPr id="4" name="Slide-Number-Placeholder-1-4">
             <a:extLst xmlns:a="http://schemas.openxmlformats.org/drawingml/2006/main">
               <a:ext uri="{FF2B5EF4-FFF2-40B4-BE49-F238E27FC236}">
-                <a16:creationId xmlns:a16="http://schemas.microsoft.com/office/drawing/2014/main" id="{CC53238A-606A-4942-BC38-74D44299B97A}"/>
+                <a16:creationId xmlns:a16="http://schemas.microsoft.com/office/drawing/2014/main" id="{38B34ED9-125F-4A49-B12F-D4633C33D92F}"/>
               </a:ext>
             </a:extLst>
           </p:cNvPr>
@@ -5775,7 +5799,7 @@
           <p:cNvPr id="5" name="Title-2-5">
             <a:extLst xmlns:a="http://schemas.openxmlformats.org/drawingml/2006/main">
               <a:ext uri="{FF2B5EF4-FFF2-40B4-BE49-F238E27FC236}">
-                <a16:creationId xmlns:a16="http://schemas.microsoft.com/office/drawing/2014/main" id="{12595828-3042-48CA-835A-10BEEF774F15}"/>
+                <a16:creationId xmlns:a16="http://schemas.microsoft.com/office/drawing/2014/main" id="{79E1A775-5ED4-4068-8419-689460974ED3}"/>
               </a:ext>
             </a:extLst>
           </p:cNvPr>
@@ -5832,7 +5856,7 @@
           <p:cNvPr id="6" name="Content-Placeholder-9-6">
             <a:extLst xmlns:a="http://schemas.openxmlformats.org/drawingml/2006/main">
               <a:ext uri="{FF2B5EF4-FFF2-40B4-BE49-F238E27FC236}">
-                <a16:creationId xmlns:a16="http://schemas.microsoft.com/office/drawing/2014/main" id="{F9F2B298-8F97-4F60-A36E-FBB878F4A50C}"/>
+                <a16:creationId xmlns:a16="http://schemas.microsoft.com/office/drawing/2014/main" id="{C77010D8-7185-413B-BE3F-414BD0E27929}"/>
               </a:ext>
             </a:extLst>
           </p:cNvPr>
@@ -5879,7 +5903,7 @@
                 <a:ea typeface="Helvetica Neue"/>
                 <a:cs typeface="Helvetica Neue"/>
               </a:rPr>
-              <a:t>Assertions passing</a:t>
+              <a:t>Controller + UI assertions</a:t>
             </a:r>
           </a:p>
         </p:txBody>
@@ -5889,7 +5913,7 @@
           <p:cNvPr id="7" name="Content-Placeholder-10-7">
             <a:extLst xmlns:a="http://schemas.openxmlformats.org/drawingml/2006/main">
               <a:ext uri="{FF2B5EF4-FFF2-40B4-BE49-F238E27FC236}">
-                <a16:creationId xmlns:a16="http://schemas.microsoft.com/office/drawing/2014/main" id="{7A417D00-F1F6-4A2A-A5B8-8EBB2B60C88A}"/>
+                <a16:creationId xmlns:a16="http://schemas.microsoft.com/office/drawing/2014/main" id="{CF2C3242-23DD-498F-A0A7-0D4EA5CDCEF7}"/>
               </a:ext>
             </a:extLst>
           </p:cNvPr>
@@ -5946,7 +5970,7 @@
           <p:cNvPr id="8" name="Content-Placeholder-11-8">
             <a:extLst xmlns:a="http://schemas.openxmlformats.org/drawingml/2006/main">
               <a:ext uri="{FF2B5EF4-FFF2-40B4-BE49-F238E27FC236}">
-                <a16:creationId xmlns:a16="http://schemas.microsoft.com/office/drawing/2014/main" id="{4A0F8389-1622-4125-96C6-C0260FC3C708}"/>
+                <a16:creationId xmlns:a16="http://schemas.microsoft.com/office/drawing/2014/main" id="{346CF599-113C-4148-9143-41EE5278BCA4}"/>
               </a:ext>
             </a:extLst>
           </p:cNvPr>
@@ -6003,7 +6027,7 @@
           <p:cNvPr id="9" name="Content-Placeholder-9-9">
             <a:extLst xmlns:a="http://schemas.openxmlformats.org/drawingml/2006/main">
               <a:ext uri="{FF2B5EF4-FFF2-40B4-BE49-F238E27FC236}">
-                <a16:creationId xmlns:a16="http://schemas.microsoft.com/office/drawing/2014/main" id="{40A45B02-7D33-4563-9A41-3F40B5E97BB3}"/>
+                <a16:creationId xmlns:a16="http://schemas.microsoft.com/office/drawing/2014/main" id="{D0D4C20D-AC6E-431F-8762-1A084BDCB6CC}"/>
               </a:ext>
             </a:extLst>
           </p:cNvPr>
@@ -6060,7 +6084,7 @@
           <p:cNvPr id="10" name="Content-Placeholder-9-10">
             <a:extLst xmlns:a="http://schemas.openxmlformats.org/drawingml/2006/main">
               <a:ext uri="{FF2B5EF4-FFF2-40B4-BE49-F238E27FC236}">
-                <a16:creationId xmlns:a16="http://schemas.microsoft.com/office/drawing/2014/main" id="{56578480-1D2F-4A18-8668-14F64459A784}"/>
+                <a16:creationId xmlns:a16="http://schemas.microsoft.com/office/drawing/2014/main" id="{791F8347-C2DF-4E1A-A284-F273F10A602C}"/>
               </a:ext>
             </a:extLst>
           </p:cNvPr>
@@ -6117,7 +6141,7 @@
           <p:cNvPr id="11" name="Content-Placeholder-9-11">
             <a:extLst xmlns:a="http://schemas.openxmlformats.org/drawingml/2006/main">
               <a:ext uri="{FF2B5EF4-FFF2-40B4-BE49-F238E27FC236}">
-                <a16:creationId xmlns:a16="http://schemas.microsoft.com/office/drawing/2014/main" id="{4EF2BEE7-28FA-4112-9201-30BB4D126E7D}"/>
+                <a16:creationId xmlns:a16="http://schemas.microsoft.com/office/drawing/2014/main" id="{B3CF58D1-8F5F-4731-AAEA-20B77CAF4513}"/>
               </a:ext>
             </a:extLst>
           </p:cNvPr>
@@ -6174,7 +6198,7 @@
           <p:cNvPr id="12" name="Content-Placeholder-15-12">
             <a:extLst xmlns:a="http://schemas.openxmlformats.org/drawingml/2006/main">
               <a:ext uri="{FF2B5EF4-FFF2-40B4-BE49-F238E27FC236}">
-                <a16:creationId xmlns:a16="http://schemas.microsoft.com/office/drawing/2014/main" id="{F21C807F-6E67-4E97-BDD1-E48EC21A124F}"/>
+                <a16:creationId xmlns:a16="http://schemas.microsoft.com/office/drawing/2014/main" id="{B8B395CF-A0A4-432D-A458-7EDFE430408C}"/>
               </a:ext>
             </a:extLst>
           </p:cNvPr>
@@ -6254,7 +6278,7 @@
                 <a:ea typeface="Helvetica Neue"/>
                 <a:cs typeface="Helvetica Neue"/>
               </a:rPr>
-              <a:t>The suite covers donor eligibility, expiry rules, priority ordering, exact-type matching, inventory counts, atomic fulfillment, and file round-trips.</a:t>
+              <a:t>The suite covers eligibility, priority, atomic matching, persistence, safe editing, dashboard counts, and headless refresh of all five Swing panels.</a:t>
             </a:r>
           </a:p>
         </p:txBody>
@@ -6262,7 +6286,7 @@
     </p:spTree>
     <p:extLst>
       <p:ext uri="{BB962C8B-B14F-4D97-AF65-F5344CB8AC3E}">
-        <p14:creationId xmlns:p14="http://schemas.microsoft.com/office/powerpoint/2010/main" val="1960007244"/>
+        <p14:creationId xmlns:p14="http://schemas.microsoft.com/office/powerpoint/2010/main" val="214766013"/>
       </p:ext>
     </p:extLst>
   </p:cSld>

</xml_diff>